<commit_message>
chore(challenge): update deck messaging - Copilot for non-developers via dual UI modes
</commit_message>
<xml_diff>
--- a/presentations/gh-copilot-chat-app-enterprise-challenge.pptx
+++ b/presentations/gh-copilot-chat-app-enterprise-challenge.pptx
@@ -3162,7 +3162,7 @@
               </a:defRPr>
             </a:pPr>
             <a:r>
-              <a:t>Enterprise-Ready Desktop Chat Interface — Powered by GitHub Copilot SDK</a:t>
+              <a:t>Bringing Copilot to Non-Developers — Simple Mode + Advanced Mode</a:t>
             </a:r>
           </a:p>
         </p:txBody>
@@ -3212,7 +3212,7 @@
               </a:defRPr>
             </a:pPr>
             <a:r>
-              <a:t>Teams use Copilot across CLI, IDE, and browser — fragmented experience</a:t>
+              <a:t>Copilot has been developer-centric — non-engineers lack access</a:t>
             </a:r>
           </a:p>
           <a:p>
@@ -3227,7 +3227,7 @@
               </a:defRPr>
             </a:pPr>
             <a:r>
-              <a:t>No standard way to deploy a governed, desktop-first chat interface</a:t>
+              <a:t>Casual AI users want a simple chat, not CLI or IDE</a:t>
             </a:r>
           </a:p>
           <a:p>
@@ -3242,7 +3242,7 @@
               </a:defRPr>
             </a:pPr>
             <a:r>
-              <a:t>Enterprises need policy-aware AI tools with operational transparency</a:t>
+              <a:t>Adding a UI layer opens Copilot to the entire workforce</a:t>
             </a:r>
           </a:p>
         </p:txBody>
@@ -3277,7 +3277,7 @@
               </a:defRPr>
             </a:pPr>
             <a:r>
-              <a:t>What</a:t>
+              <a:t>Dual-Mode UX</a:t>
             </a:r>
           </a:p>
           <a:p>
@@ -3292,7 +3292,7 @@
               </a:defRPr>
             </a:pPr>
             <a:r>
-              <a:t>Modern multi-session chat UI (React 19 + TypeScript)</a:t>
+              <a:t>Simple Mode: ChatGPT-like interface for light AI users</a:t>
             </a:r>
           </a:p>
           <a:p>
@@ -3307,7 +3307,7 @@
               </a:defRPr>
             </a:pPr>
             <a:r>
-              <a:t>Per-session model / mode / tool-policy controls</a:t>
+              <a:t>Advanced Mode: model selection, tool-policy, multi-session</a:t>
             </a:r>
           </a:p>
           <a:p>
@@ -3387,7 +3387,7 @@
               </a:defRPr>
             </a:pPr>
             <a:r>
-              <a:t>Standardize Copilot usage across the organization</a:t>
+              <a:t>Capture light AI users → boost org-wide Copilot adoption</a:t>
             </a:r>
           </a:p>
           <a:p>
@@ -3402,7 +3402,7 @@
               </a:defRPr>
             </a:pPr>
             <a:r>
-              <a:t>Reduce context-switching and onboarding cost</a:t>
+              <a:t>Reduce onboarding cost with familiar chat UX</a:t>
             </a:r>
           </a:p>
           <a:p>
@@ -3417,7 +3417,7 @@
               </a:defRPr>
             </a:pPr>
             <a:r>
-              <a:t>Reusable pattern for customer deployments</a:t>
+              <a:t>Reusable deployment pattern for customer scenarios</a:t>
             </a:r>
           </a:p>
         </p:txBody>
@@ -3497,7 +3497,7 @@
               </a:defRPr>
             </a:pPr>
             <a:r>
-              <a:t>Docs: EXE installer guide + developer quickstart</a:t>
+              <a:t>EXE installer: non-engineers can install without dev tools</a:t>
             </a:r>
           </a:p>
           <a:p>
@@ -3881,7 +3881,7 @@
               </a:defRPr>
             </a:pPr>
             <a:r>
-              <a:t>Screenshots</a:t>
+              <a:t>Dual-Mode Screenshots</a:t>
             </a:r>
           </a:p>
           <a:p>
@@ -3896,7 +3896,7 @@
               </a:defRPr>
             </a:pPr>
             <a:r>
-              <a:t>Advanced Mode — full chat interface with streaming</a:t>
+              <a:t>Simple Mode — anyone can chat with Copilot</a:t>
             </a:r>
           </a:p>
           <a:p>
@@ -3911,7 +3911,7 @@
               </a:defRPr>
             </a:pPr>
             <a:r>
-              <a:t>Simple Mode — lightweight conversation view</a:t>
+              <a:t>Advanced Mode — power users configure everything</a:t>
             </a:r>
           </a:p>
           <a:p>

</xml_diff>